<commit_message>
Deck slide 8: the rebuilt contact sheet, with the E4 row self-evident
The sheet now names each row once (rotated "Elt 4" on its first
thumbnail), titles each thumbnail with its channel and page ("Rx  pg 4")
and prints each panel's rms underneath, so element 4's dead row reads
"rms 0 / 4.3e-15 / 0 / 6.9e-16 / 3.4e-16 / 0" against element 5's
"1.6e+02" one row down.  Figure unmodified, as always; the caption and
footnote say what to see and carry the column measurement.

Co-Authored-By: Claude Opus 5 <noreply@anthropic.com>
Claude-Session: https://claude.ai/code/session_01RuX6Hc5txP1E9QGjcSo42d
</commit_message>
<xml_diff>
--- a/demo_session/deck_dwd_march.pptx
+++ b/demo_session/deck_dwd_march.pptx
@@ -4786,8 +4786,8 @@
         </p:blipFill>
         <p:spPr>
           <a:xfrm>
-            <a:off x="2741858" y="1298448"/>
-            <a:ext cx="1145683" cy="3994912"/>
+            <a:off x="2793942" y="1298448"/>
+            <a:ext cx="1041514" cy="4213352"/>
           </a:xfrm>
           <a:prstGeom prst="rect">
             <a:avLst/>
@@ -4802,8 +4802,8 @@
         </p:nvSpPr>
         <p:spPr>
           <a:xfrm>
-            <a:off x="411480" y="5311647"/>
-            <a:ext cx="5806440" cy="394208"/>
+            <a:off x="411480" y="5530088"/>
+            <a:ext cx="5806440" cy="724408"/>
           </a:xfrm>
           <a:prstGeom prst="rect">
             <a:avLst/>
@@ -4828,7 +4828,7 @@
                 </a:solidFill>
                 <a:latin typeface="Arial"/>
               </a:rPr>
-              <a:t>The dW/dx contact sheet: every one of the 138 channels as a thumbnail, each labelled with the full-size page it is drawn on (E5 Rx p04 ...).</a:t>
+              <a:t>The dW/dx contact sheet: 23 rows (one per element, group, source) x 6 DOFs. Each row is named once on the left, each thumbnail carries its channel and page ("Rx  pg 4") and its own rms underneath -- so a dead channel announces itself instead of being painted at full colour scale.</a:t>
             </a:r>
           </a:p>
         </p:txBody>
@@ -5567,7 +5567,7 @@
                 </a:solidFill>
                 <a:latin typeface="Arial"/>
               </a:rPr>
-              <a:t>THE E4 ROW IS ROUND-OFF, NOT SIGNAL.  Element 4 is the virtual centre segment; its six columns are dead -- Rx, Rz, Tz are EXACTLY zero (0 non-zero of 54 595 rows, so nothing is drawn) and Ry, Tx, Ty carry max 1.1e-14 / 8.5e-16 mm on 612 / 8 641 / 2 491 rows, taking 3-4 distinct values each: the finite-difference floor of a re-trace, 17 decades below element 5 (max 1.4e+03, rms 1.6e+02).  The thumbnails are autoscaled with no colorbar, so those few pixels are painted across the full jet range.  flag_zero_norm_channels catches the column and the driver drops it from the saved .mat; the figures are drawn before that drop.</a:t>
+              <a:t>THE E4 ROW IS ROUND-OFF, AND THE SHEET NOW SAYS SO.  Element 4 is the virtual centre segment; its six columns are dead -- Rx, Rz, Tz are EXACTLY zero over all 54 595 rows (nothing drawn, rms 0) and Ry, Tx, Ty carry max 1.06e-14 / 8.47e-16 / 8.47e-16 mm on 612 / 8 641 / 2 491 rows, taking 3-4 distinct values each: the finite-difference floor of a re-trace, 17 decades below element 5 (column max 1.405e+03, rms 1.614e+02).  Autoscaled thumbnails with no colorbar painted those few pixels across the full jet range, which reads as structure; the per-panel rms is the scale the colours were missing (rms 4.3e-15 against rms 1.6e+02 one row down).  Panel rms is of the map AS DRAWN -- valid pixels, piston removed -- so it differs from the column rms over all rows.  flag_zero_norm_channels catches the column and the driver drops it from the saved .mat; the figures are drawn before that drop.</a:t>
             </a:r>
           </a:p>
         </p:txBody>
@@ -5580,7 +5580,7 @@
         </p:nvSpPr>
         <p:spPr>
           <a:xfrm>
-            <a:off x="6400800" y="4322826"/>
+            <a:off x="6400800" y="5016246"/>
             <a:ext cx="5394960" cy="274320"/>
           </a:xfrm>
           <a:prstGeom prst="rect">

</xml_diff>